<commit_message>
fotos y archivo final
</commit_message>
<xml_diff>
--- a/Poster/Formato.Poster.DipFICA.pptx
+++ b/Poster/Formato.Poster.DipFICA.pptx
@@ -11331,7 +11331,7 @@
                 <a:cs typeface="Calibri"/>
                 <a:sym typeface="Calibri"/>
               </a:rPr>
-              <a:t>Desde el análisis de datos podemos encontrar patrones que nos lleven a la búsqueda de resultados. Esto lo podemos encontrar desde varias técnicas de recolección de datos. Una de las más comunes para extraer datos relevantes y en tiempo real es el web </a:t>
+              <a:t>Desde el análisis de datos podemos encontrar patrones que nos lleven a la búsqueda de resultados. Una de las más comunes para extraer datos relevantes y en tiempo real es el web </a:t>
             </a:r>
             <a:r>
               <a:rPr lang="es-ES" sz="3800" dirty="0" err="1">
@@ -11422,7 +11422,7 @@
                 <a:cs typeface="Calibri"/>
                 <a:sym typeface="Calibri"/>
               </a:rPr>
-              <a:t>Bajo este ejercicio se presenta entonces el análisis de la percepción social por medio de películas de culto. Bajo esta mirada se pretende analizar la percepción social de comentarios de películas de culto enfocadas en el subconsciente social, desde las percepciones de amor, duelo, tecnología y dinámicas relacionales.</a:t>
+              <a:t>Bajo este ejercicio se presenta entonces el análisis de la percepción social por medio de películas de culto. Bajo esta mirada se pretende analizar la percepción social de comentarios de películas de culto enfocadas en el subconsciente social, desde las percepciones de amor, duelo, tecnología y dinámicas relacionales. Para esto se usa Reddit como red social genuina, evitando sesgos sociales. </a:t>
             </a:r>
           </a:p>
           <a:p>
@@ -11514,7 +11514,7 @@
         <p:spPr>
           <a:xfrm>
             <a:off x="384174" y="22897463"/>
-            <a:ext cx="15122525" cy="4770496"/>
+            <a:ext cx="15122525" cy="3600945"/>
           </a:xfrm>
           <a:prstGeom prst="rect">
             <a:avLst/>
@@ -11530,14 +11530,15 @@
           </a:bodyPr>
           <a:lstStyle/>
           <a:p>
-            <a:pPr marL="0" marR="0" lvl="0" indent="0" algn="just" rtl="0">
-              <a:spcBef>
-                <a:spcPts val="0"/>
-              </a:spcBef>
-              <a:spcAft>
-                <a:spcPts val="0"/>
-              </a:spcAft>
-              <a:buNone/>
+            <a:pPr marL="571500" marR="0" lvl="0" indent="-571500" algn="just" rtl="0">
+              <a:spcBef>
+                <a:spcPts val="0"/>
+              </a:spcBef>
+              <a:spcAft>
+                <a:spcPts val="0"/>
+              </a:spcAft>
+              <a:buFont typeface="Arial" panose="020B0604020202020204" pitchFamily="34" charset="0"/>
+              <a:buChar char="•"/>
             </a:pPr>
             <a:r>
               <a:rPr lang="es-CO" sz="3800" dirty="0">
@@ -11549,7 +11550,55 @@
                 <a:cs typeface="Calibri"/>
                 <a:sym typeface="Calibri"/>
               </a:rPr>
-              <a:t>Analizar los comentarios de varias película de cultos, encontrando patrones en los datos, por medio de la polaridad de los comentarios asociados. Esto desde la extracción de datos con Web </a:t>
+              <a:t>Analizar los comentarios de varias película de cultos, encontrando patrones en los datos, por medio de la polaridad de los comentarios asociados.</a:t>
+            </a:r>
+          </a:p>
+          <a:p>
+            <a:pPr marL="571500" marR="0" lvl="0" indent="-571500" algn="just" rtl="0">
+              <a:spcBef>
+                <a:spcPts val="0"/>
+              </a:spcBef>
+              <a:spcAft>
+                <a:spcPts val="0"/>
+              </a:spcAft>
+              <a:buFont typeface="Arial" panose="020B0604020202020204" pitchFamily="34" charset="0"/>
+              <a:buChar char="•"/>
+            </a:pPr>
+            <a:r>
+              <a:rPr lang="es-CO" sz="3800" dirty="0">
+                <a:solidFill>
+                  <a:schemeClr val="dk1"/>
+                </a:solidFill>
+                <a:latin typeface="Calibri"/>
+                <a:ea typeface="Calibri"/>
+                <a:cs typeface="Calibri"/>
+                <a:sym typeface="Calibri"/>
+              </a:rPr>
+              <a:t>Identifica patrones entre los datos analizados.</a:t>
+            </a:r>
+          </a:p>
+          <a:p>
+            <a:pPr marL="571500" marR="0" lvl="0" indent="-571500" algn="just" rtl="0">
+              <a:spcBef>
+                <a:spcPts val="0"/>
+              </a:spcBef>
+              <a:spcAft>
+                <a:spcPts val="0"/>
+              </a:spcAft>
+              <a:buFont typeface="Arial" panose="020B0604020202020204" pitchFamily="34" charset="0"/>
+              <a:buChar char="•"/>
+            </a:pPr>
+            <a:r>
+              <a:rPr lang="es-CO" sz="3800" dirty="0">
+                <a:solidFill>
+                  <a:schemeClr val="dk1"/>
+                </a:solidFill>
+                <a:latin typeface="Calibri"/>
+                <a:ea typeface="Calibri"/>
+                <a:cs typeface="Calibri"/>
+                <a:sym typeface="Calibri"/>
+              </a:rPr>
+              <a:t>Generar modelos de aprendizaje no supervisado desde </a:t>
             </a:r>
             <a:r>
               <a:rPr lang="es-CO" sz="3800" dirty="0" err="1">
@@ -11561,7 +11610,7 @@
                 <a:cs typeface="Calibri"/>
                 <a:sym typeface="Calibri"/>
               </a:rPr>
-              <a:t>Scarping</a:t>
+              <a:t>Kmeans</a:t>
             </a:r>
             <a:r>
               <a:rPr lang="es-CO" sz="3800" dirty="0">
@@ -11573,28 +11622,8 @@
                 <a:cs typeface="Calibri"/>
                 <a:sym typeface="Calibri"/>
               </a:rPr>
-              <a:t> de Reddit. </a:t>
+              <a:t>.</a:t>
             </a:r>
-          </a:p>
-          <a:p>
-            <a:pPr marL="0" marR="0" lvl="0" indent="0" algn="just" rtl="0">
-              <a:spcBef>
-                <a:spcPts val="0"/>
-              </a:spcBef>
-              <a:spcAft>
-                <a:spcPts val="0"/>
-              </a:spcAft>
-              <a:buNone/>
-            </a:pPr>
-            <a:endParaRPr lang="es-CO" sz="3800" dirty="0">
-              <a:solidFill>
-                <a:schemeClr val="dk1"/>
-              </a:solidFill>
-              <a:latin typeface="Calibri"/>
-              <a:ea typeface="Calibri"/>
-              <a:cs typeface="Calibri"/>
-              <a:sym typeface="Calibri"/>
-            </a:endParaRPr>
           </a:p>
           <a:p>
             <a:pPr marL="0" marR="0" lvl="0" indent="0" algn="just" rtl="0">
@@ -11616,7 +11645,7 @@
                 <a:cs typeface="Calibri"/>
                 <a:sym typeface="Calibri"/>
               </a:rPr>
-              <a:t>Desde este ejercicio se pretende identificar patrones encontrados en los comentarios asociados a estas películas. Encontrando clústeres que determinen correlación entre variables, determinando puntos en común para un análisis objetivo de la información. </a:t>
+              <a:t> </a:t>
             </a:r>
             <a:endParaRPr dirty="0"/>
           </a:p>
@@ -11746,8 +11775,8 @@
         </p:nvSpPr>
         <p:spPr>
           <a:xfrm>
-            <a:off x="22679711" y="12938044"/>
-            <a:ext cx="9196232" cy="3416279"/>
+            <a:off x="16262614" y="13025693"/>
+            <a:ext cx="15656373" cy="2862282"/>
           </a:xfrm>
           <a:prstGeom prst="rect">
             <a:avLst/>
@@ -11763,14 +11792,15 @@
           </a:bodyPr>
           <a:lstStyle/>
           <a:p>
-            <a:pPr marL="0" marR="0" lvl="0" indent="0" algn="just" rtl="0">
-              <a:spcBef>
-                <a:spcPts val="0"/>
-              </a:spcBef>
-              <a:spcAft>
-                <a:spcPts val="0"/>
-              </a:spcAft>
-              <a:buNone/>
+            <a:pPr marL="571500" marR="0" lvl="0" indent="-571500" algn="just" rtl="0">
+              <a:spcBef>
+                <a:spcPts val="0"/>
+              </a:spcBef>
+              <a:spcAft>
+                <a:spcPts val="0"/>
+              </a:spcAft>
+              <a:buFont typeface="Arial" panose="020B0604020202020204" pitchFamily="34" charset="0"/>
+              <a:buChar char="•"/>
             </a:pPr>
             <a:r>
               <a:rPr lang="es-CO" sz="3600" dirty="0">
@@ -11786,7 +11816,10 @@
             </a:r>
           </a:p>
           <a:p>
-            <a:pPr algn="just"/>
+            <a:pPr marL="571500" indent="-571500" algn="just">
+              <a:buFont typeface="Arial" panose="020B0604020202020204" pitchFamily="34" charset="0"/>
+              <a:buChar char="•"/>
+            </a:pPr>
             <a:r>
               <a:rPr lang="es-CO" sz="3600" dirty="0">
                 <a:solidFill>
@@ -11797,7 +11830,7 @@
                 <a:cs typeface="Calibri"/>
                 <a:sym typeface="Calibri"/>
               </a:rPr>
-              <a:t>Para este ejercicio se realiza la </a:t>
+              <a:t>Desde el </a:t>
             </a:r>
             <a:r>
               <a:rPr lang="es-CO" sz="3600" dirty="0" err="1">
@@ -11809,7 +11842,7 @@
                 <a:cs typeface="Calibri"/>
                 <a:sym typeface="Calibri"/>
               </a:rPr>
-              <a:t>clusterización</a:t>
+              <a:t>Silhouette</a:t>
             </a:r>
             <a:r>
               <a:rPr lang="es-CO" sz="3600" dirty="0">
@@ -11821,7 +11854,79 @@
                 <a:cs typeface="Calibri"/>
                 <a:sym typeface="Calibri"/>
               </a:rPr>
-              <a:t> para hacer un modelo no supervisado. </a:t>
+              <a:t> y </a:t>
+            </a:r>
+            <a:r>
+              <a:rPr lang="es-CO" sz="3600" dirty="0" err="1">
+                <a:solidFill>
+                  <a:schemeClr val="dk1"/>
+                </a:solidFill>
+                <a:latin typeface="Calibri"/>
+                <a:ea typeface="Calibri"/>
+                <a:cs typeface="Calibri"/>
+                <a:sym typeface="Calibri"/>
+              </a:rPr>
+              <a:t>elbow</a:t>
+            </a:r>
+            <a:r>
+              <a:rPr lang="es-CO" sz="3600" dirty="0">
+                <a:solidFill>
+                  <a:schemeClr val="dk1"/>
+                </a:solidFill>
+                <a:latin typeface="Calibri"/>
+                <a:ea typeface="Calibri"/>
+                <a:cs typeface="Calibri"/>
+                <a:sym typeface="Calibri"/>
+              </a:rPr>
+              <a:t> </a:t>
+            </a:r>
+            <a:r>
+              <a:rPr lang="es-CO" sz="3600" dirty="0" err="1">
+                <a:solidFill>
+                  <a:schemeClr val="dk1"/>
+                </a:solidFill>
+                <a:latin typeface="Calibri"/>
+                <a:ea typeface="Calibri"/>
+                <a:cs typeface="Calibri"/>
+                <a:sym typeface="Calibri"/>
+              </a:rPr>
+              <a:t>plow</a:t>
+            </a:r>
+            <a:r>
+              <a:rPr lang="es-CO" sz="3600" dirty="0">
+                <a:solidFill>
+                  <a:schemeClr val="dk1"/>
+                </a:solidFill>
+                <a:latin typeface="Calibri"/>
+                <a:ea typeface="Calibri"/>
+                <a:cs typeface="Calibri"/>
+                <a:sym typeface="Calibri"/>
+              </a:rPr>
+              <a:t>, identificamos que tenemos 6 </a:t>
+            </a:r>
+            <a:r>
+              <a:rPr lang="es-CO" sz="3600" dirty="0" err="1">
+                <a:solidFill>
+                  <a:schemeClr val="dk1"/>
+                </a:solidFill>
+                <a:latin typeface="Calibri"/>
+                <a:ea typeface="Calibri"/>
+                <a:cs typeface="Calibri"/>
+                <a:sym typeface="Calibri"/>
+              </a:rPr>
+              <a:t>clusters</a:t>
+            </a:r>
+            <a:r>
+              <a:rPr lang="es-CO" sz="3600" dirty="0">
+                <a:solidFill>
+                  <a:schemeClr val="dk1"/>
+                </a:solidFill>
+                <a:latin typeface="Calibri"/>
+                <a:ea typeface="Calibri"/>
+                <a:cs typeface="Calibri"/>
+                <a:sym typeface="Calibri"/>
+              </a:rPr>
+              <a:t> diferenciados. </a:t>
             </a:r>
           </a:p>
           <a:p>
@@ -12487,7 +12592,7 @@
         <p:spPr>
           <a:xfrm>
             <a:off x="523345" y="28965387"/>
-            <a:ext cx="15226078" cy="8279149"/>
+            <a:ext cx="15226078" cy="2431394"/>
           </a:xfrm>
           <a:prstGeom prst="rect">
             <a:avLst/>
@@ -12548,154 +12653,6 @@
               </a:rPr>
               <a:t> que recolectaba la información de los comentarios asociados a varios link (De las películas de culto analizadas). Para este criterio se buscaron películas de culto basadas en el duelo y la tecnología, teniendo relación con el enfoque presentado anteriormente. </a:t>
             </a:r>
-          </a:p>
-          <a:p>
-            <a:pPr marL="0" marR="0" lvl="0" indent="0" algn="just" rtl="0">
-              <a:spcBef>
-                <a:spcPts val="0"/>
-              </a:spcBef>
-              <a:spcAft>
-                <a:spcPts val="0"/>
-              </a:spcAft>
-              <a:buNone/>
-            </a:pPr>
-            <a:endParaRPr lang="es-CO" sz="3800" dirty="0">
-              <a:solidFill>
-                <a:schemeClr val="dk1"/>
-              </a:solidFill>
-              <a:latin typeface="Calibri"/>
-              <a:ea typeface="Calibri"/>
-              <a:cs typeface="Calibri"/>
-              <a:sym typeface="Calibri"/>
-            </a:endParaRPr>
-          </a:p>
-          <a:p>
-            <a:pPr marL="0" marR="0" lvl="0" indent="0" algn="just" rtl="0">
-              <a:spcBef>
-                <a:spcPts val="0"/>
-              </a:spcBef>
-              <a:spcAft>
-                <a:spcPts val="0"/>
-              </a:spcAft>
-              <a:buNone/>
-            </a:pPr>
-            <a:r>
-              <a:rPr lang="es-CO" sz="3800" dirty="0">
-                <a:solidFill>
-                  <a:schemeClr val="dk1"/>
-                </a:solidFill>
-                <a:latin typeface="Calibri"/>
-                <a:ea typeface="Calibri"/>
-                <a:cs typeface="Calibri"/>
-                <a:sym typeface="Calibri"/>
-              </a:rPr>
-              <a:t>Primero se realizo un análisis explicativo de datos, centrándose en detectar y eliminar los </a:t>
-            </a:r>
-            <a:r>
-              <a:rPr lang="es-CO" sz="3800" dirty="0" err="1">
-                <a:solidFill>
-                  <a:schemeClr val="dk1"/>
-                </a:solidFill>
-                <a:latin typeface="Calibri"/>
-                <a:ea typeface="Calibri"/>
-                <a:cs typeface="Calibri"/>
-                <a:sym typeface="Calibri"/>
-              </a:rPr>
-              <a:t>Outliers</a:t>
-            </a:r>
-            <a:r>
-              <a:rPr lang="es-CO" sz="3800" dirty="0">
-                <a:solidFill>
-                  <a:schemeClr val="dk1"/>
-                </a:solidFill>
-                <a:latin typeface="Calibri"/>
-                <a:ea typeface="Calibri"/>
-                <a:cs typeface="Calibri"/>
-                <a:sym typeface="Calibri"/>
-              </a:rPr>
-              <a:t> para poder tener un análisis real de la información. Aquí se usaron varios recursos estadísticos como el </a:t>
-            </a:r>
-            <a:r>
-              <a:rPr lang="es-CO" sz="3800" dirty="0" err="1">
-                <a:solidFill>
-                  <a:schemeClr val="dk1"/>
-                </a:solidFill>
-                <a:latin typeface="Calibri"/>
-                <a:ea typeface="Calibri"/>
-                <a:cs typeface="Calibri"/>
-                <a:sym typeface="Calibri"/>
-              </a:rPr>
-              <a:t>Boxplot</a:t>
-            </a:r>
-            <a:r>
-              <a:rPr lang="es-CO" sz="3800" dirty="0">
-                <a:solidFill>
-                  <a:schemeClr val="dk1"/>
-                </a:solidFill>
-                <a:latin typeface="Calibri"/>
-                <a:ea typeface="Calibri"/>
-                <a:cs typeface="Calibri"/>
-                <a:sym typeface="Calibri"/>
-              </a:rPr>
-              <a:t> y el diagrama de violín para identificar la polaridad de los comentarios por película, encontrando la media, y la distribución de los comentarios. Luego de esto se analiza por medio de una cauterización con </a:t>
-            </a:r>
-            <a:r>
-              <a:rPr lang="es-CO" sz="3800" dirty="0" err="1">
-                <a:solidFill>
-                  <a:schemeClr val="dk1"/>
-                </a:solidFill>
-                <a:latin typeface="Calibri"/>
-                <a:ea typeface="Calibri"/>
-                <a:cs typeface="Calibri"/>
-                <a:sym typeface="Calibri"/>
-              </a:rPr>
-              <a:t>Kmeans</a:t>
-            </a:r>
-            <a:r>
-              <a:rPr lang="es-CO" sz="3800" dirty="0">
-                <a:solidFill>
-                  <a:schemeClr val="dk1"/>
-                </a:solidFill>
-                <a:latin typeface="Calibri"/>
-                <a:ea typeface="Calibri"/>
-                <a:cs typeface="Calibri"/>
-                <a:sym typeface="Calibri"/>
-              </a:rPr>
-              <a:t>, las tendencias de los datos, encontrando dos </a:t>
-            </a:r>
-            <a:r>
-              <a:rPr lang="es-CO" sz="3800" dirty="0" err="1">
-                <a:solidFill>
-                  <a:schemeClr val="dk1"/>
-                </a:solidFill>
-                <a:latin typeface="Calibri"/>
-                <a:ea typeface="Calibri"/>
-                <a:cs typeface="Calibri"/>
-                <a:sym typeface="Calibri"/>
-              </a:rPr>
-              <a:t>clusters</a:t>
-            </a:r>
-            <a:r>
-              <a:rPr lang="es-CO" sz="3800" dirty="0">
-                <a:solidFill>
-                  <a:schemeClr val="dk1"/>
-                </a:solidFill>
-                <a:latin typeface="Calibri"/>
-                <a:ea typeface="Calibri"/>
-                <a:cs typeface="Calibri"/>
-                <a:sym typeface="Calibri"/>
-              </a:rPr>
-              <a:t> relevantes para este caso. identificando patrones en los comentarios asociados por película, y en contexto general de las películas de culto analizadas. </a:t>
-            </a:r>
-            <a:endParaRPr sz="3800" dirty="0">
-              <a:solidFill>
-                <a:schemeClr val="dk1"/>
-              </a:solidFill>
-              <a:latin typeface="Calibri"/>
-              <a:ea typeface="Calibri"/>
-              <a:cs typeface="Calibri"/>
-              <a:sym typeface="Calibri"/>
-            </a:endParaRPr>
           </a:p>
         </p:txBody>
       </p:sp>
@@ -12876,10 +12833,10 @@
       </p:pic>
       <p:sp>
         <p:nvSpPr>
-          <p:cNvPr id="6" name="TextBox 5">
+          <p:cNvPr id="12" name="TextBox 11">
             <a:extLst>
               <a:ext uri="{FF2B5EF4-FFF2-40B4-BE49-F238E27FC236}">
-                <a16:creationId xmlns:a16="http://schemas.microsoft.com/office/drawing/2014/main" id="{4FAD3A37-B5F5-BC72-DEBE-D6B3541E9B3E}"/>
+                <a16:creationId xmlns:a16="http://schemas.microsoft.com/office/drawing/2014/main" id="{152796B9-F8BE-A785-BB59-C77A441E2185}"/>
               </a:ext>
             </a:extLst>
           </p:cNvPr>
@@ -12888,8 +12845,8 @@
         </p:nvSpPr>
         <p:spPr>
           <a:xfrm>
-            <a:off x="22679711" y="16000907"/>
-            <a:ext cx="9023347" cy="2523768"/>
+            <a:off x="16555186" y="29415075"/>
+            <a:ext cx="15320757" cy="6401753"/>
           </a:xfrm>
           <a:prstGeom prst="rect">
             <a:avLst/>
@@ -12902,14 +12859,15 @@
           </a:bodyPr>
           <a:lstStyle/>
           <a:p>
-            <a:pPr marL="0" marR="0" lvl="0" indent="0" algn="just" rtl="0">
-              <a:spcBef>
-                <a:spcPts val="0"/>
-              </a:spcBef>
-              <a:spcAft>
-                <a:spcPts val="0"/>
-              </a:spcAft>
-              <a:buNone/>
+            <a:pPr marL="571500" marR="0" lvl="0" indent="-571500" algn="just" rtl="0">
+              <a:spcBef>
+                <a:spcPts val="0"/>
+              </a:spcBef>
+              <a:spcAft>
+                <a:spcPts val="0"/>
+              </a:spcAft>
+              <a:buFont typeface="Arial" panose="020B0604020202020204" pitchFamily="34" charset="0"/>
+              <a:buChar char="•"/>
             </a:pPr>
             <a:r>
               <a:rPr lang="es-CO" sz="3600" dirty="0">
@@ -12921,79 +12879,7 @@
                 <a:cs typeface="Calibri"/>
                 <a:sym typeface="Calibri"/>
               </a:rPr>
-              <a:t>Desde el </a:t>
-            </a:r>
-            <a:r>
-              <a:rPr lang="es-CO" sz="3600" dirty="0" err="1">
-                <a:solidFill>
-                  <a:schemeClr val="dk1"/>
-                </a:solidFill>
-                <a:latin typeface="Calibri"/>
-                <a:ea typeface="Calibri"/>
-                <a:cs typeface="Calibri"/>
-                <a:sym typeface="Calibri"/>
-              </a:rPr>
-              <a:t>Silhouette</a:t>
-            </a:r>
-            <a:r>
-              <a:rPr lang="es-CO" sz="3600" dirty="0">
-                <a:solidFill>
-                  <a:schemeClr val="dk1"/>
-                </a:solidFill>
-                <a:latin typeface="Calibri"/>
-                <a:ea typeface="Calibri"/>
-                <a:cs typeface="Calibri"/>
-                <a:sym typeface="Calibri"/>
-              </a:rPr>
-              <a:t> y </a:t>
-            </a:r>
-            <a:r>
-              <a:rPr lang="es-CO" sz="3600" dirty="0" err="1">
-                <a:solidFill>
-                  <a:schemeClr val="dk1"/>
-                </a:solidFill>
-                <a:latin typeface="Calibri"/>
-                <a:ea typeface="Calibri"/>
-                <a:cs typeface="Calibri"/>
-                <a:sym typeface="Calibri"/>
-              </a:rPr>
-              <a:t>elbow</a:t>
-            </a:r>
-            <a:r>
-              <a:rPr lang="es-CO" sz="3600" dirty="0">
-                <a:solidFill>
-                  <a:schemeClr val="dk1"/>
-                </a:solidFill>
-                <a:latin typeface="Calibri"/>
-                <a:ea typeface="Calibri"/>
-                <a:cs typeface="Calibri"/>
-                <a:sym typeface="Calibri"/>
-              </a:rPr>
-              <a:t> </a:t>
-            </a:r>
-            <a:r>
-              <a:rPr lang="es-CO" sz="3600" dirty="0" err="1">
-                <a:solidFill>
-                  <a:schemeClr val="dk1"/>
-                </a:solidFill>
-                <a:latin typeface="Calibri"/>
-                <a:ea typeface="Calibri"/>
-                <a:cs typeface="Calibri"/>
-                <a:sym typeface="Calibri"/>
-              </a:rPr>
-              <a:t>plow</a:t>
-            </a:r>
-            <a:r>
-              <a:rPr lang="es-CO" sz="3600" dirty="0">
-                <a:solidFill>
-                  <a:schemeClr val="dk1"/>
-                </a:solidFill>
-                <a:latin typeface="Calibri"/>
-                <a:ea typeface="Calibri"/>
-                <a:cs typeface="Calibri"/>
-                <a:sym typeface="Calibri"/>
-              </a:rPr>
-              <a:t>, identificamos que tenemos dos </a:t>
+              <a:t>las película de culto son ampliamente comentadas, identificando patrones en común, generando una distribución de 6 clústeres, aunque en comparación por puntaje se denotan los 6 </a:t>
             </a:r>
             <a:r>
               <a:rPr lang="es-CO" sz="3600" dirty="0" err="1">
@@ -13017,98 +12903,19 @@
                 <a:cs typeface="Calibri"/>
                 <a:sym typeface="Calibri"/>
               </a:rPr>
-              <a:t> diferenciados. Analizando la información se identifican la variación entre 6 clústeres.</a:t>
+              <a:t> encontrados.</a:t>
             </a:r>
-            <a:endParaRPr lang="es-CO" sz="1400" dirty="0">
-              <a:solidFill>
-                <a:schemeClr val="dk1"/>
-              </a:solidFill>
-              <a:latin typeface="Calibri"/>
-              <a:ea typeface="Calibri"/>
-              <a:cs typeface="Calibri"/>
-              <a:sym typeface="Calibri"/>
-            </a:endParaRPr>
           </a:p>
           <a:p>
-            <a:pPr lvl="0" algn="just"/>
-            <a:endParaRPr lang="es-CO" sz="1400" dirty="0">
-              <a:solidFill>
-                <a:schemeClr val="dk1"/>
-              </a:solidFill>
-              <a:latin typeface="Calibri"/>
-              <a:ea typeface="Calibri"/>
-              <a:cs typeface="Calibri"/>
-              <a:sym typeface="Calibri"/>
-            </a:endParaRPr>
-          </a:p>
-        </p:txBody>
-      </p:sp>
-      <p:pic>
-        <p:nvPicPr>
-          <p:cNvPr id="10" name="Picture 9">
-            <a:extLst>
-              <a:ext uri="{FF2B5EF4-FFF2-40B4-BE49-F238E27FC236}">
-                <a16:creationId xmlns:a16="http://schemas.microsoft.com/office/drawing/2014/main" id="{CF59FD57-495D-3533-A3BB-95D040FD200E}"/>
-              </a:ext>
-            </a:extLst>
-          </p:cNvPr>
-          <p:cNvPicPr>
-            <a:picLocks noChangeAspect="1"/>
-          </p:cNvPicPr>
-          <p:nvPr/>
-        </p:nvPicPr>
-        <p:blipFill>
-          <a:blip r:embed="rId6"/>
-          <a:stretch>
-            <a:fillRect/>
-          </a:stretch>
-        </p:blipFill>
-        <p:spPr>
-          <a:xfrm>
-            <a:off x="16470647" y="16464729"/>
-            <a:ext cx="5428209" cy="3602228"/>
-          </a:xfrm>
-          <a:prstGeom prst="rect">
-            <a:avLst/>
-          </a:prstGeom>
-        </p:spPr>
-      </p:pic>
-      <p:sp>
-        <p:nvSpPr>
-          <p:cNvPr id="12" name="TextBox 11">
-            <a:extLst>
-              <a:ext uri="{FF2B5EF4-FFF2-40B4-BE49-F238E27FC236}">
-                <a16:creationId xmlns:a16="http://schemas.microsoft.com/office/drawing/2014/main" id="{152796B9-F8BE-A785-BB59-C77A441E2185}"/>
-              </a:ext>
-            </a:extLst>
-          </p:cNvPr>
-          <p:cNvSpPr txBox="1"/>
-          <p:nvPr/>
-        </p:nvSpPr>
-        <p:spPr>
-          <a:xfrm>
-            <a:off x="16555186" y="29415075"/>
-            <a:ext cx="15320757" cy="7509748"/>
-          </a:xfrm>
-          <a:prstGeom prst="rect">
-            <a:avLst/>
-          </a:prstGeom>
-          <a:noFill/>
-        </p:spPr>
-        <p:txBody>
-          <a:bodyPr wrap="square">
-            <a:spAutoFit/>
-          </a:bodyPr>
-          <a:lstStyle/>
-          <a:p>
-            <a:pPr marL="0" marR="0" lvl="0" indent="0" algn="just" rtl="0">
-              <a:spcBef>
-                <a:spcPts val="0"/>
-              </a:spcBef>
-              <a:spcAft>
-                <a:spcPts val="0"/>
-              </a:spcAft>
-              <a:buNone/>
+            <a:pPr marL="571500" marR="0" lvl="0" indent="-571500" algn="just" rtl="0">
+              <a:spcBef>
+                <a:spcPts val="0"/>
+              </a:spcBef>
+              <a:spcAft>
+                <a:spcPts val="0"/>
+              </a:spcAft>
+              <a:buFont typeface="Arial" panose="020B0604020202020204" pitchFamily="34" charset="0"/>
+              <a:buChar char="•"/>
             </a:pPr>
             <a:r>
               <a:rPr lang="es-CO" sz="3600" dirty="0">
@@ -13120,7 +12927,7 @@
                 <a:cs typeface="Calibri"/>
                 <a:sym typeface="Calibri"/>
               </a:rPr>
-              <a:t>Se evidencia que las película de culto son ampliamente comentadas, identificando patrones en común, generando una distribución de 6 clústeres, entre los cuales se reconoce que la mayoría de los datos están ubicados en </a:t>
+              <a:t>Si nos basamos en la puntación media y la distribución en </a:t>
             </a:r>
             <a:r>
               <a:rPr lang="es-CO" sz="3600" dirty="0" err="1">
@@ -13144,18 +12951,91 @@
                 <a:cs typeface="Calibri"/>
                 <a:sym typeface="Calibri"/>
               </a:rPr>
-              <a:t> 4. </a:t>
+              <a:t>, evidenciamos una gran cantidad de películas con predominancia del </a:t>
+            </a:r>
+            <a:r>
+              <a:rPr lang="es-CO" sz="3600" dirty="0" err="1">
+                <a:solidFill>
+                  <a:schemeClr val="dk1"/>
+                </a:solidFill>
+                <a:latin typeface="Calibri"/>
+                <a:ea typeface="Calibri"/>
+                <a:cs typeface="Calibri"/>
+                <a:sym typeface="Calibri"/>
+              </a:rPr>
+              <a:t>cluster</a:t>
+            </a:r>
+            <a:r>
+              <a:rPr lang="es-CO" sz="3600" dirty="0">
+                <a:solidFill>
+                  <a:schemeClr val="dk1"/>
+                </a:solidFill>
+                <a:latin typeface="Calibri"/>
+                <a:ea typeface="Calibri"/>
+                <a:cs typeface="Calibri"/>
+                <a:sym typeface="Calibri"/>
+              </a:rPr>
+              <a:t> 4 y 2, reconociendo que la mayoría de comentarios que pertenecen al </a:t>
+            </a:r>
+            <a:r>
+              <a:rPr lang="es-CO" sz="3600" dirty="0" err="1">
+                <a:solidFill>
+                  <a:schemeClr val="dk1"/>
+                </a:solidFill>
+                <a:latin typeface="Calibri"/>
+                <a:ea typeface="Calibri"/>
+                <a:cs typeface="Calibri"/>
+                <a:sym typeface="Calibri"/>
+              </a:rPr>
+              <a:t>cluster</a:t>
+            </a:r>
+            <a:r>
+              <a:rPr lang="es-CO" sz="3600" dirty="0">
+                <a:solidFill>
+                  <a:schemeClr val="dk1"/>
+                </a:solidFill>
+                <a:latin typeface="Calibri"/>
+                <a:ea typeface="Calibri"/>
+                <a:cs typeface="Calibri"/>
+                <a:sym typeface="Calibri"/>
+              </a:rPr>
+              <a:t> 4, suelen ser positivos o superiores a los del </a:t>
+            </a:r>
+            <a:r>
+              <a:rPr lang="es-CO" sz="3600" dirty="0" err="1">
+                <a:solidFill>
+                  <a:schemeClr val="dk1"/>
+                </a:solidFill>
+                <a:latin typeface="Calibri"/>
+                <a:ea typeface="Calibri"/>
+                <a:cs typeface="Calibri"/>
+                <a:sym typeface="Calibri"/>
+              </a:rPr>
+              <a:t>cluster</a:t>
+            </a:r>
+            <a:r>
+              <a:rPr lang="es-CO" sz="3600" dirty="0">
+                <a:solidFill>
+                  <a:schemeClr val="dk1"/>
+                </a:solidFill>
+                <a:latin typeface="Calibri"/>
+                <a:ea typeface="Calibri"/>
+                <a:cs typeface="Calibri"/>
+                <a:sym typeface="Calibri"/>
+              </a:rPr>
+              <a:t> 2. </a:t>
             </a:r>
           </a:p>
           <a:p>
-            <a:pPr marL="0" marR="0" lvl="0" indent="0" algn="just" rtl="0">
-              <a:spcBef>
-                <a:spcPts val="0"/>
-              </a:spcBef>
-              <a:spcAft>
-                <a:spcPts val="0"/>
-              </a:spcAft>
-              <a:buNone/>
+            <a:pPr marL="571500" marR="0" lvl="0" indent="-571500" algn="just" rtl="0">
+              <a:spcBef>
+                <a:spcPts val="0"/>
+              </a:spcBef>
+              <a:spcAft>
+                <a:spcPts val="0"/>
+              </a:spcAft>
+              <a:buFont typeface="Arial" panose="020B0604020202020204" pitchFamily="34" charset="0"/>
+              <a:buChar char="•"/>
             </a:pPr>
             <a:r>
               <a:rPr lang="es-CO" sz="3600" dirty="0">
@@ -13167,31 +13047,7 @@
                 <a:cs typeface="Calibri"/>
                 <a:sym typeface="Calibri"/>
               </a:rPr>
-              <a:t>Aunque los comentarios son variados, la mayoría de ellos están dentro de un promedio de 16 palabras, Con una polaridad moderada, de 0.11 </a:t>
-            </a:r>
-            <a:r>
-              <a:rPr lang="es-CO" sz="3600" dirty="0" err="1">
-                <a:solidFill>
-                  <a:schemeClr val="dk1"/>
-                </a:solidFill>
-                <a:latin typeface="Calibri"/>
-                <a:ea typeface="Calibri"/>
-                <a:cs typeface="Calibri"/>
-                <a:sym typeface="Calibri"/>
-              </a:rPr>
-              <a:t>aprox</a:t>
-            </a:r>
-            <a:r>
-              <a:rPr lang="es-CO" sz="3600" dirty="0">
-                <a:solidFill>
-                  <a:schemeClr val="dk1"/>
-                </a:solidFill>
-                <a:latin typeface="Calibri"/>
-                <a:ea typeface="Calibri"/>
-                <a:cs typeface="Calibri"/>
-                <a:sym typeface="Calibri"/>
-              </a:rPr>
-              <a:t>, con una subjetividad media, identificando opinión peor también hechos dentro del comentario y tienen un puntaje alto, identificando que son películas altamente vistas y por ende son llamadas películas de culto. Esto nos lleva a pensar en una relevancia del contenido de la película, en relación a las vivencias subjetivas de los espectadores, que llegan a ver estas películas con alto interés en entender situaciones especificas, y por ende los lleva a pensar mas allá, y dejar comentarios asociados al sentimiento encontrado. </a:t>
+              <a:t>Se evidencia la relevancia del contenido de la película, en relación a las vivencias subjetivas de los espectadores, que llegan a ver estas películas con alto interés en entender situaciones especificas, y por ende los lleva a pensar mas allá, y dejar comentarios asociados al sentimiento encontrado. </a:t>
             </a:r>
             <a:endParaRPr lang="es-CO" sz="1400" dirty="0">
               <a:solidFill>
@@ -13232,7 +13088,7 @@
           <p:nvPr/>
         </p:nvPicPr>
         <p:blipFill>
-          <a:blip r:embed="rId7"/>
+          <a:blip r:embed="rId6"/>
           <a:srcRect l="3189"/>
           <a:stretch>
             <a:fillRect/>
@@ -13240,7 +13096,7 @@
         </p:blipFill>
         <p:spPr>
           <a:xfrm>
-            <a:off x="16649824" y="20336009"/>
+            <a:off x="16848100" y="20973676"/>
             <a:ext cx="10835185" cy="2927027"/>
           </a:xfrm>
           <a:prstGeom prst="rect">
@@ -13262,8 +13118,8 @@
         </p:nvSpPr>
         <p:spPr>
           <a:xfrm>
-            <a:off x="16649824" y="23889672"/>
-            <a:ext cx="14858834" cy="3293209"/>
+            <a:off x="16649866" y="24087156"/>
+            <a:ext cx="14677799" cy="4401205"/>
           </a:xfrm>
           <a:prstGeom prst="rect">
             <a:avLst/>
@@ -13295,7 +13151,31 @@
                 <a:cs typeface="Calibri"/>
                 <a:sym typeface="Calibri"/>
               </a:rPr>
-              <a:t>Aun así podemos notar que la mayoría de los comentarios están dentro del clúster 4, es decir la mayoría de comentarios, son breves, pero significativos. Enfatizando en una polaridad, que tiende a ser alta. Además de tener una subjetividad media, mezclando opiniones con hechos, los cuales suelen tener un puntaje alto en la calificación asociada al comentario. </a:t>
+              <a:t>Aun así podemos notar que la mayoría de los comentarios están dentro del clúster 4, es decir la mayoría de comentarios, son breves, pero significativos. Enfatizando en una polaridad, que tiende a ser alta. Además de tener una subjetividad media, mezclando opiniones con hechos, los cuales suelen tener un puntaje alto en la calificación asociada al comentario. Se identifican también los </a:t>
+            </a:r>
+            <a:r>
+              <a:rPr lang="es-CO" sz="3600" dirty="0" err="1">
+                <a:solidFill>
+                  <a:schemeClr val="dk1"/>
+                </a:solidFill>
+                <a:latin typeface="Calibri"/>
+                <a:ea typeface="Calibri"/>
+                <a:cs typeface="Calibri"/>
+                <a:sym typeface="Calibri"/>
+              </a:rPr>
+              <a:t>clusters</a:t>
+            </a:r>
+            <a:r>
+              <a:rPr lang="es-CO" sz="3600" dirty="0">
+                <a:solidFill>
+                  <a:schemeClr val="dk1"/>
+                </a:solidFill>
+                <a:latin typeface="Calibri"/>
+                <a:ea typeface="Calibri"/>
+                <a:cs typeface="Calibri"/>
+                <a:sym typeface="Calibri"/>
+              </a:rPr>
+              <a:t> desde la comparación con numero de caracteres y puntaje. </a:t>
             </a:r>
           </a:p>
           <a:p>
@@ -13334,10 +13214,40 @@
       </p:sp>
       <p:pic>
         <p:nvPicPr>
-          <p:cNvPr id="25" name="Picture 24">
+          <p:cNvPr id="33" name="Picture 32">
             <a:extLst>
               <a:ext uri="{FF2B5EF4-FFF2-40B4-BE49-F238E27FC236}">
-                <a16:creationId xmlns:a16="http://schemas.microsoft.com/office/drawing/2014/main" id="{8C426550-DC57-56F2-36E2-0C2D6B0C59E7}"/>
+                <a16:creationId xmlns:a16="http://schemas.microsoft.com/office/drawing/2014/main" id="{52A2F24B-29E9-5184-BA2F-5036AF36E176}"/>
+              </a:ext>
+            </a:extLst>
+          </p:cNvPr>
+          <p:cNvPicPr>
+            <a:picLocks noChangeAspect="1"/>
+          </p:cNvPicPr>
+          <p:nvPr/>
+        </p:nvPicPr>
+        <p:blipFill>
+          <a:blip r:embed="rId7"/>
+          <a:stretch>
+            <a:fillRect/>
+          </a:stretch>
+        </p:blipFill>
+        <p:spPr>
+          <a:xfrm>
+            <a:off x="729296" y="31551617"/>
+            <a:ext cx="12777153" cy="4298414"/>
+          </a:xfrm>
+          <a:prstGeom prst="rect">
+            <a:avLst/>
+          </a:prstGeom>
+        </p:spPr>
+      </p:pic>
+      <p:pic>
+        <p:nvPicPr>
+          <p:cNvPr id="37" name="Picture 36" descr="A chart with different colored circles&#10;&#10;AI-generated content may be incorrect.">
+            <a:extLst>
+              <a:ext uri="{FF2B5EF4-FFF2-40B4-BE49-F238E27FC236}">
+                <a16:creationId xmlns:a16="http://schemas.microsoft.com/office/drawing/2014/main" id="{2F248621-E1CF-56DF-D62F-FE7A5F3501AC}"/>
               </a:ext>
             </a:extLst>
           </p:cNvPr>
@@ -13348,15 +13258,44 @@
         </p:nvPicPr>
         <p:blipFill>
           <a:blip r:embed="rId8"/>
-          <a:srcRect l="631" t="-4653" r="-631" b="4653"/>
           <a:stretch>
             <a:fillRect/>
           </a:stretch>
         </p:blipFill>
         <p:spPr>
           <a:xfrm>
-            <a:off x="16219570" y="12804098"/>
-            <a:ext cx="5840276" cy="3494591"/>
+            <a:off x="16649866" y="15549557"/>
+            <a:ext cx="5942463" cy="4734645"/>
+          </a:xfrm>
+          <a:prstGeom prst="rect">
+            <a:avLst/>
+          </a:prstGeom>
+        </p:spPr>
+      </p:pic>
+      <p:pic>
+        <p:nvPicPr>
+          <p:cNvPr id="39" name="Picture 38" descr="A graph of different colored squares&#10;&#10;AI-generated content may be incorrect.">
+            <a:extLst>
+              <a:ext uri="{FF2B5EF4-FFF2-40B4-BE49-F238E27FC236}">
+                <a16:creationId xmlns:a16="http://schemas.microsoft.com/office/drawing/2014/main" id="{D8BCC328-DA9A-5F81-AA39-8FC0823D51C4}"/>
+              </a:ext>
+            </a:extLst>
+          </p:cNvPr>
+          <p:cNvPicPr>
+            <a:picLocks noChangeAspect="1"/>
+          </p:cNvPicPr>
+          <p:nvPr/>
+        </p:nvPicPr>
+        <p:blipFill>
+          <a:blip r:embed="rId9"/>
+          <a:stretch>
+            <a:fillRect/>
+          </a:stretch>
+        </p:blipFill>
+        <p:spPr>
+          <a:xfrm>
+            <a:off x="22793377" y="15635626"/>
+            <a:ext cx="8141101" cy="4871315"/>
           </a:xfrm>
           <a:prstGeom prst="rect">
             <a:avLst/>

</xml_diff>